<commit_message>
feat(demo): add complete project tour video in MP4 and WebM formats, remove corrupt recordings
</commit_message>
<xml_diff>
--- a/demo/StudyTrack_DevOps_Capstone_Presentation.pptx
+++ b/demo/StudyTrack_DevOps_Capstone_Presentation.pptx
@@ -7221,6 +7221,96 @@
               </a:defRPr>
             </a:pPr>
             <a:r>
+              <a:t>• 📹 demo/studytrack_full_tour.mp4</a:t>
+            </a:r>
+          </a:p>
+          <a:p>
+            <a:pPr>
+              <a:spcAft>
+                <a:spcPts val="300"/>
+              </a:spcAft>
+              <a:defRPr sz="1050">
+                <a:solidFill>
+                  <a:srgbClr val="F8FAFC"/>
+                </a:solidFill>
+              </a:defRPr>
+            </a:pPr>
+            <a:r>
+              <a:t>•    • Broadcast-grade HD video tour of complete application &amp; cloud infrastructure</a:t>
+            </a:r>
+          </a:p>
+          <a:p>
+            <a:pPr>
+              <a:spcAft>
+                <a:spcPts val="300"/>
+              </a:spcAft>
+              <a:defRPr sz="1050">
+                <a:solidFill>
+                  <a:srgbClr val="F8FAFC"/>
+                </a:solidFill>
+              </a:defRPr>
+            </a:pPr>
+            <a:r>
+              <a:t>• </a:t>
+            </a:r>
+          </a:p>
+          <a:p>
+            <a:pPr>
+              <a:spcAft>
+                <a:spcPts val="300"/>
+              </a:spcAft>
+              <a:defRPr sz="1050">
+                <a:solidFill>
+                  <a:srgbClr val="F8FAFC"/>
+                </a:solidFill>
+              </a:defRPr>
+            </a:pPr>
+            <a:r>
+              <a:t>• 📹 demo/studytrack_full_tour.webm</a:t>
+            </a:r>
+          </a:p>
+          <a:p>
+            <a:pPr>
+              <a:spcAft>
+                <a:spcPts val="300"/>
+              </a:spcAft>
+              <a:defRPr sz="1050">
+                <a:solidFill>
+                  <a:srgbClr val="F8FAFC"/>
+                </a:solidFill>
+              </a:defRPr>
+            </a:pPr>
+            <a:r>
+              <a:t>•    • Full video demonstration in native high-resolution WebM format</a:t>
+            </a:r>
+          </a:p>
+          <a:p>
+            <a:pPr>
+              <a:spcAft>
+                <a:spcPts val="300"/>
+              </a:spcAft>
+              <a:defRPr sz="1050">
+                <a:solidFill>
+                  <a:srgbClr val="F8FAFC"/>
+                </a:solidFill>
+              </a:defRPr>
+            </a:pPr>
+            <a:r>
+              <a:t>• </a:t>
+            </a:r>
+          </a:p>
+          <a:p>
+            <a:pPr>
+              <a:spcAft>
+                <a:spcPts val="300"/>
+              </a:spcAft>
+              <a:defRPr sz="1050">
+                <a:solidFill>
+                  <a:srgbClr val="F8FAFC"/>
+                </a:solidFill>
+              </a:defRPr>
+            </a:pPr>
+            <a:r>
               <a:t>• 📹 demo/studytrack_full_demo.webp</a:t>
             </a:r>
           </a:p>
@@ -7236,97 +7326,7 @@
               </a:defRPr>
             </a:pPr>
             <a:r>
-              <a:t>•    • High-resolution video recording of complete application &amp; Swagger API</a:t>
-            </a:r>
-          </a:p>
-          <a:p>
-            <a:pPr>
-              <a:spcAft>
-                <a:spcPts val="300"/>
-              </a:spcAft>
-              <a:defRPr sz="1050">
-                <a:solidFill>
-                  <a:srgbClr val="F8FAFC"/>
-                </a:solidFill>
-              </a:defRPr>
-            </a:pPr>
-            <a:r>
-              <a:t>• </a:t>
-            </a:r>
-          </a:p>
-          <a:p>
-            <a:pPr>
-              <a:spcAft>
-                <a:spcPts val="300"/>
-              </a:spcAft>
-              <a:defRPr sz="1050">
-                <a:solidFill>
-                  <a:srgbClr val="F8FAFC"/>
-                </a:solidFill>
-              </a:defRPr>
-            </a:pPr>
-            <a:r>
-              <a:t>• 📹 demo/studytrack_live_ingress_demo.webp</a:t>
-            </a:r>
-          </a:p>
-          <a:p>
-            <a:pPr>
-              <a:spcAft>
-                <a:spcPts val="300"/>
-              </a:spcAft>
-              <a:defRPr sz="1050">
-                <a:solidFill>
-                  <a:srgbClr val="F8FAFC"/>
-                </a:solidFill>
-              </a:defRPr>
-            </a:pPr>
-            <a:r>
-              <a:t>•    • Video recording of live AWS EKS Ingress ELB access &amp; task creation</a:t>
-            </a:r>
-          </a:p>
-          <a:p>
-            <a:pPr>
-              <a:spcAft>
-                <a:spcPts val="300"/>
-              </a:spcAft>
-              <a:defRPr sz="1050">
-                <a:solidFill>
-                  <a:srgbClr val="F8FAFC"/>
-                </a:solidFill>
-              </a:defRPr>
-            </a:pPr>
-            <a:r>
-              <a:t>• </a:t>
-            </a:r>
-          </a:p>
-          <a:p>
-            <a:pPr>
-              <a:spcAft>
-                <a:spcPts val="300"/>
-              </a:spcAft>
-              <a:defRPr sz="1050">
-                <a:solidFill>
-                  <a:srgbClr val="F8FAFC"/>
-                </a:solidFill>
-              </a:defRPr>
-            </a:pPr>
-            <a:r>
-              <a:t>• 📹 demo/studytrack_monitoring_demo.webp</a:t>
-            </a:r>
-          </a:p>
-          <a:p>
-            <a:pPr>
-              <a:spcAft>
-                <a:spcPts val="300"/>
-              </a:spcAft>
-              <a:defRPr sz="1050">
-                <a:solidFill>
-                  <a:srgbClr val="F8FAFC"/>
-                </a:solidFill>
-              </a:defRPr>
-            </a:pPr>
-            <a:r>
-              <a:t>•    • Video recording of Prometheus query UI &amp; Grafana dashboards</a:t>
+              <a:t>•    • Smooth animated video preview for markdown documentation</a:t>
             </a:r>
           </a:p>
           <a:p>

</xml_diff>

<commit_message>
feat(branding): market exclusively as StudyTrack with academic coursework analytics and distinct study features
</commit_message>
<xml_diff>
--- a/demo/StudyTrack_DevOps_Capstone_Presentation.pptx
+++ b/demo/StudyTrack_DevOps_Capstone_Presentation.pptx
@@ -3184,7 +3184,7 @@
               </a:defRPr>
             </a:pPr>
             <a:r>
-              <a:t>StudyTrack &amp; TaskBoard</a:t>
+              <a:t>StudyTrack</a:t>
             </a:r>
           </a:p>
           <a:p>
@@ -3214,7 +3214,7 @@
               </a:defRPr>
             </a:pPr>
             <a:r>
-              <a:t>Candidate: shubh-aarambh  |  Domain: Learning Management System &amp; TaskBoard</a:t>
+              <a:t>Candidate: shubh-aarambh  |  Domain: Academic Coursework &amp; Deadline Management System</a:t>
             </a:r>
           </a:p>
           <a:p>
@@ -3809,7 +3809,7 @@
               </a:defRPr>
             </a:pPr>
             <a:r>
-              <a:t>• Helm packaging with values for taskboard namespace</a:t>
+              <a:t>• Helm packaging with values for production cluster namespace</a:t>
             </a:r>
           </a:p>
           <a:p>
@@ -4072,7 +4072,7 @@
               </a:defRPr>
             </a:pPr>
             <a:r>
-              <a:t>1. StudyTrack TaskBoard UI</a:t>
+              <a:t>1. StudyTrack Academic Workspace UI</a:t>
             </a:r>
           </a:p>
           <a:p>
@@ -4099,7 +4099,7 @@
               </a:defRPr>
             </a:pPr>
             <a:r>
-              <a:t>• Modern glassmorphism UI with live task/assignment tracking</a:t>
+              <a:t>• Modern glassmorphism UI with live assignment &amp; deadline tracking</a:t>
             </a:r>
           </a:p>
           <a:p>
@@ -4559,7 +4559,7 @@
               </a:defRPr>
             </a:pPr>
             <a:r>
-              <a:t>• Stateful workload deployed in Kubernetes taskboard namespace</a:t>
+              <a:t>• Stateful workload deployed in Kubernetes production namespace</a:t>
             </a:r>
           </a:p>
           <a:p>
@@ -5631,7 +5631,7 @@
               </a:defRPr>
             </a:pPr>
             <a:r>
-              <a:t>• Namespace taskboard: backend (2 replicas), frontend (2 replicas), postgres (1)</a:t>
+              <a:t>• Production Workloads: backend (2 replicas), frontend (2 replicas), postgres (1)</a:t>
             </a:r>
           </a:p>
           <a:p>
@@ -6859,7 +6859,7 @@
               </a:defRPr>
             </a:pPr>
             <a:r>
-              <a:t>• ✓ 1. Application: StudyTrack / TaskBoard UI interactive and responsive</a:t>
+              <a:t>• ✓ 1. Application: StudyTrack Academic UI interactive and responsive</a:t>
             </a:r>
           </a:p>
           <a:p>
@@ -6994,7 +6994,7 @@
               </a:defRPr>
             </a:pPr>
             <a:r>
-              <a:t>• ✓ 10. Kubernetes: All pods &amp; services running in taskboard namespace</a:t>
+              <a:t>• ✓ 10. Kubernetes: All pods &amp; services running in production cluster namespace</a:t>
             </a:r>
           </a:p>
           <a:p>

</xml_diff>

<commit_message>
feat(demo): add browser-viewable PDF presentation and keep single MP4 project tour video
</commit_message>
<xml_diff>
--- a/demo/StudyTrack_DevOps_Capstone_Presentation.pptx
+++ b/demo/StudyTrack_DevOps_Capstone_Presentation.pptx
@@ -7176,6 +7176,51 @@
               </a:defRPr>
             </a:pPr>
             <a:r>
+              <a:t>• 📄 demo/StudyTrack_DevOps_Capstone_Presentation.pdf</a:t>
+            </a:r>
+          </a:p>
+          <a:p>
+            <a:pPr>
+              <a:spcAft>
+                <a:spcPts val="300"/>
+              </a:spcAft>
+              <a:defRPr sz="1050">
+                <a:solidFill>
+                  <a:srgbClr val="F8FAFC"/>
+                </a:solidFill>
+              </a:defRPr>
+            </a:pPr>
+            <a:r>
+              <a:t>•    • Browser-viewable slide deck (opens directly without downloading)</a:t>
+            </a:r>
+          </a:p>
+          <a:p>
+            <a:pPr>
+              <a:spcAft>
+                <a:spcPts val="300"/>
+              </a:spcAft>
+              <a:defRPr sz="1050">
+                <a:solidFill>
+                  <a:srgbClr val="F8FAFC"/>
+                </a:solidFill>
+              </a:defRPr>
+            </a:pPr>
+            <a:r>
+              <a:t>• </a:t>
+            </a:r>
+          </a:p>
+          <a:p>
+            <a:pPr>
+              <a:spcAft>
+                <a:spcPts val="300"/>
+              </a:spcAft>
+              <a:defRPr sz="1050">
+                <a:solidFill>
+                  <a:srgbClr val="F8FAFC"/>
+                </a:solidFill>
+              </a:defRPr>
+            </a:pPr>
+            <a:r>
               <a:t>• 📁 demo/StudyTrack_DevOps_Capstone_Presentation.pptx</a:t>
             </a:r>
           </a:p>
@@ -7191,7 +7236,7 @@
               </a:defRPr>
             </a:pPr>
             <a:r>
-              <a:t>•    • Complete 9-slide executive &amp; technical slide deck with evidence</a:t>
+              <a:t>•    • Complete 9-slide executive &amp; technical slide deck source</a:t>
             </a:r>
           </a:p>
           <a:p>
@@ -7236,97 +7281,7 @@
               </a:defRPr>
             </a:pPr>
             <a:r>
-              <a:t>•    • Broadcast-grade HD video tour of complete application &amp; cloud infrastructure</a:t>
-            </a:r>
-          </a:p>
-          <a:p>
-            <a:pPr>
-              <a:spcAft>
-                <a:spcPts val="300"/>
-              </a:spcAft>
-              <a:defRPr sz="1050">
-                <a:solidFill>
-                  <a:srgbClr val="F8FAFC"/>
-                </a:solidFill>
-              </a:defRPr>
-            </a:pPr>
-            <a:r>
-              <a:t>• </a:t>
-            </a:r>
-          </a:p>
-          <a:p>
-            <a:pPr>
-              <a:spcAft>
-                <a:spcPts val="300"/>
-              </a:spcAft>
-              <a:defRPr sz="1050">
-                <a:solidFill>
-                  <a:srgbClr val="F8FAFC"/>
-                </a:solidFill>
-              </a:defRPr>
-            </a:pPr>
-            <a:r>
-              <a:t>• 📹 demo/studytrack_full_tour.webm</a:t>
-            </a:r>
-          </a:p>
-          <a:p>
-            <a:pPr>
-              <a:spcAft>
-                <a:spcPts val="300"/>
-              </a:spcAft>
-              <a:defRPr sz="1050">
-                <a:solidFill>
-                  <a:srgbClr val="F8FAFC"/>
-                </a:solidFill>
-              </a:defRPr>
-            </a:pPr>
-            <a:r>
-              <a:t>•    • Full video demonstration in native high-resolution WebM format</a:t>
-            </a:r>
-          </a:p>
-          <a:p>
-            <a:pPr>
-              <a:spcAft>
-                <a:spcPts val="300"/>
-              </a:spcAft>
-              <a:defRPr sz="1050">
-                <a:solidFill>
-                  <a:srgbClr val="F8FAFC"/>
-                </a:solidFill>
-              </a:defRPr>
-            </a:pPr>
-            <a:r>
-              <a:t>• </a:t>
-            </a:r>
-          </a:p>
-          <a:p>
-            <a:pPr>
-              <a:spcAft>
-                <a:spcPts val="300"/>
-              </a:spcAft>
-              <a:defRPr sz="1050">
-                <a:solidFill>
-                  <a:srgbClr val="F8FAFC"/>
-                </a:solidFill>
-              </a:defRPr>
-            </a:pPr>
-            <a:r>
-              <a:t>• 📹 demo/studytrack_full_demo.webp</a:t>
-            </a:r>
-          </a:p>
-          <a:p>
-            <a:pPr>
-              <a:spcAft>
-                <a:spcPts val="300"/>
-              </a:spcAft>
-              <a:defRPr sz="1050">
-                <a:solidFill>
-                  <a:srgbClr val="F8FAFC"/>
-                </a:solidFill>
-              </a:defRPr>
-            </a:pPr>
-            <a:r>
-              <a:t>•    • Smooth animated video preview for markdown documentation</a:t>
+              <a:t>•    • Complete broadcast-grade HD video tour of all 15 rubric criteria</a:t>
             </a:r>
           </a:p>
           <a:p>

</xml_diff>

<commit_message>
feat(demo): embed inline-playing tour GIF directly in GitHub README, remove download-only MP4
</commit_message>
<xml_diff>
--- a/demo/StudyTrack_DevOps_Capstone_Presentation.pptx
+++ b/demo/StudyTrack_DevOps_Capstone_Presentation.pptx
@@ -7266,22 +7266,22 @@
               </a:defRPr>
             </a:pPr>
             <a:r>
-              <a:t>• 📹 demo/studytrack_full_tour.mp4</a:t>
-            </a:r>
-          </a:p>
-          <a:p>
-            <a:pPr>
-              <a:spcAft>
-                <a:spcPts val="300"/>
-              </a:spcAft>
-              <a:defRPr sz="1050">
-                <a:solidFill>
-                  <a:srgbClr val="F8FAFC"/>
-                </a:solidFill>
-              </a:defRPr>
-            </a:pPr>
-            <a:r>
-              <a:t>•    • Complete broadcast-grade HD video tour of all 15 rubric criteria</a:t>
+              <a:t>• 🎬 demo/studytrack_tour.gif</a:t>
+            </a:r>
+          </a:p>
+          <a:p>
+            <a:pPr>
+              <a:spcAft>
+                <a:spcPts val="300"/>
+              </a:spcAft>
+              <a:defRPr sz="1050">
+                <a:solidFill>
+                  <a:srgbClr val="F8FAFC"/>
+                </a:solidFill>
+              </a:defRPr>
+            </a:pPr>
+            <a:r>
+              <a:t>•    • In-browser animated tour (plays directly on GitHub without downloading)</a:t>
             </a:r>
           </a:p>
           <a:p>

</xml_diff>

<commit_message>
feat(demo): retain both in-browser animated tour GIF and broadcast HD MP4 video
</commit_message>
<xml_diff>
--- a/demo/StudyTrack_DevOps_Capstone_Presentation.pptx
+++ b/demo/StudyTrack_DevOps_Capstone_Presentation.pptx
@@ -7282,6 +7282,51 @@
             </a:pPr>
             <a:r>
               <a:t>•    • In-browser animated tour (plays directly on GitHub without downloading)</a:t>
+            </a:r>
+          </a:p>
+          <a:p>
+            <a:pPr>
+              <a:spcAft>
+                <a:spcPts val="300"/>
+              </a:spcAft>
+              <a:defRPr sz="1050">
+                <a:solidFill>
+                  <a:srgbClr val="F8FAFC"/>
+                </a:solidFill>
+              </a:defRPr>
+            </a:pPr>
+            <a:r>
+              <a:t>• </a:t>
+            </a:r>
+          </a:p>
+          <a:p>
+            <a:pPr>
+              <a:spcAft>
+                <a:spcPts val="300"/>
+              </a:spcAft>
+              <a:defRPr sz="1050">
+                <a:solidFill>
+                  <a:srgbClr val="F8FAFC"/>
+                </a:solidFill>
+              </a:defRPr>
+            </a:pPr>
+            <a:r>
+              <a:t>• 📹 demo/studytrack_full_tour.mp4</a:t>
+            </a:r>
+          </a:p>
+          <a:p>
+            <a:pPr>
+              <a:spcAft>
+                <a:spcPts val="300"/>
+              </a:spcAft>
+              <a:defRPr sz="1050">
+                <a:solidFill>
+                  <a:srgbClr val="F8FAFC"/>
+                </a:solidFill>
+              </a:defRPr>
+            </a:pPr>
+            <a:r>
+              <a:t>•    • Broadcast-grade 720p HD MP4 video recording (18.5 MB)</a:t>
             </a:r>
           </a:p>
           <a:p>

</xml_diff>